<commit_message>
Apply business-focused portfolio conclusions
</commit_message>
<xml_diff>
--- a/docs/Presentacion_Proyecto_Rotacion.pptx
+++ b/docs/Presentacion_Proyecto_Rotacion.pptx
@@ -2,21 +2,21 @@
 <file path=ppt/presentation.xml><?xml version="1.0" encoding="utf-8"?>
 <p:presentation xmlns:p="http://schemas.openxmlformats.org/presentationml/2006/main">
   <p:sldMasterIdLst>
-    <p:sldMasterId xmlns:r="http://schemas.openxmlformats.org/officeDocument/2006/relationships" id="2147483648" r:id="R9695712d3e9c4622"/>
+    <p:sldMasterId xmlns:r="http://schemas.openxmlformats.org/officeDocument/2006/relationships" id="2147483648" r:id="R446f805d99dd44ba"/>
   </p:sldMasterIdLst>
   <p:notesMasterIdLst>
-    <p:notesMasterId xmlns:r="http://schemas.openxmlformats.org/officeDocument/2006/relationships" r:id="R0210aece5b924039"/>
+    <p:notesMasterId xmlns:r="http://schemas.openxmlformats.org/officeDocument/2006/relationships" r:id="R97a8917883244c87"/>
   </p:notesMasterIdLst>
   <p:sldIdLst>
-    <p:sldId xmlns:r="http://schemas.openxmlformats.org/officeDocument/2006/relationships" id="256" r:id="R7e1e055751264d38"/>
-    <p:sldId xmlns:r="http://schemas.openxmlformats.org/officeDocument/2006/relationships" id="257" r:id="R721fb7071fda4235"/>
-    <p:sldId xmlns:r="http://schemas.openxmlformats.org/officeDocument/2006/relationships" id="258" r:id="Rff67c811c1c44bd3"/>
-    <p:sldId xmlns:r="http://schemas.openxmlformats.org/officeDocument/2006/relationships" id="259" r:id="R6a5650646ffd4f18"/>
-    <p:sldId xmlns:r="http://schemas.openxmlformats.org/officeDocument/2006/relationships" id="260" r:id="Rd52db7f731c44942"/>
-    <p:sldId xmlns:r="http://schemas.openxmlformats.org/officeDocument/2006/relationships" id="261" r:id="Re20522e428814c2f"/>
-    <p:sldId xmlns:r="http://schemas.openxmlformats.org/officeDocument/2006/relationships" id="262" r:id="Rdaa57608416f41aa"/>
-    <p:sldId xmlns:r="http://schemas.openxmlformats.org/officeDocument/2006/relationships" id="263" r:id="Rf0b5121bd8d54fb3"/>
-    <p:sldId xmlns:r="http://schemas.openxmlformats.org/officeDocument/2006/relationships" id="264" r:id="Rb2f1896b587c4606"/>
+    <p:sldId xmlns:r="http://schemas.openxmlformats.org/officeDocument/2006/relationships" id="256" r:id="R82b0342d2bf34755"/>
+    <p:sldId xmlns:r="http://schemas.openxmlformats.org/officeDocument/2006/relationships" id="257" r:id="R33dd6ffded5a42a0"/>
+    <p:sldId xmlns:r="http://schemas.openxmlformats.org/officeDocument/2006/relationships" id="258" r:id="R7f55d0d02f6a4c39"/>
+    <p:sldId xmlns:r="http://schemas.openxmlformats.org/officeDocument/2006/relationships" id="259" r:id="R373c1dfa4e51492c"/>
+    <p:sldId xmlns:r="http://schemas.openxmlformats.org/officeDocument/2006/relationships" id="260" r:id="R294ef80b0e8845fb"/>
+    <p:sldId xmlns:r="http://schemas.openxmlformats.org/officeDocument/2006/relationships" id="261" r:id="R9358700a9b0641c8"/>
+    <p:sldId xmlns:r="http://schemas.openxmlformats.org/officeDocument/2006/relationships" id="262" r:id="R54c7b98f49a74c46"/>
+    <p:sldId xmlns:r="http://schemas.openxmlformats.org/officeDocument/2006/relationships" id="263" r:id="Rf8982be3a5ce4b12"/>
+    <p:sldId xmlns:r="http://schemas.openxmlformats.org/officeDocument/2006/relationships" id="264" r:id="Rfd597fcd62ef470c"/>
   </p:sldIdLst>
   <p:sldSz cx="12192000" cy="6858000"/>
   <p:notesSz cx="6858000" cy="9144000"/>
@@ -391,7 +391,7 @@
                 <a:ea typeface="Arial"/>
                 <a:cs typeface="Arial"/>
               </a:rPr>
-              <a:t>Proyecto educativo sobre integración de datos y clasificación de rotación. Los conjuntos son de ejemplo. No representa una herramienta de decisión laboral.</a:t>
+              <a:t>Proyecto educativo de Big Data y analítica de Recursos Humanos. El recorrido integra datos, compara modelos y traduce resultados a prioridades para una empresa hipotética.</a:t>
             </a:r>
             <a:endParaRPr sz="2000" b="0" u="none">
               <a:solidFill>
@@ -483,7 +483,7 @@
                 <a:ea typeface="Arial"/>
                 <a:cs typeface="Arial"/>
               </a:rPr>
-              <a:t>El proyecto compara tres clasificadores con datos de ejemplo y muestra un prototipo de panel descriptivo.</a:t>
+              <a:t>La diapositiva resume el objetivo: preparar los datos, comparar tres clasificadores y orientar diagnósticos y acciones de retención por área.</a:t>
             </a:r>
             <a:endParaRPr sz="2000" b="0" u="none">
               <a:solidFill>
@@ -575,7 +575,7 @@
                 <a:ea typeface="Arial"/>
                 <a:cs typeface="Arial"/>
               </a:rPr>
-              <a:t>El proceso revisa calidad y claves, genera la encuesta sintética con semilla fija, ejecuta el ETL, entrena los modelos y exporta resultados.</a:t>
+              <a:t>El flujo comienza con controles de calidad, integra la encuesta mediante EmployeeNumber, construye variables con PySpark, compara los clasificadores y exporta métricas y gráficos.</a:t>
             </a:r>
             <a:endParaRPr sz="2000" b="0" u="none">
               <a:solidFill>
@@ -667,7 +667,7 @@
                 <a:ea typeface="Arial"/>
                 <a:cs typeface="Arial"/>
               </a:rPr>
-              <a:t>La regresión logística obtiene la mayor ROC-AUC, mientras el bosque aleatorio alcanza el F1 optimizado más alto. El ajuste del umbral usa las mismas predicciones OOF, por lo que el F1 es exploratorio.</a:t>
+              <a:t>La gráfica compara ROC-AUC, PR-AUC y F1 de los tres modelos con predicciones OOF. Regresión Logística lidera ROC-AUC y PR-AUC; Random Forest obtiene el F1 comparativo más alto.</a:t>
             </a:r>
             <a:endParaRPr sz="2000" b="0" u="none">
               <a:solidFill>
@@ -759,7 +759,7 @@
                 <a:ea typeface="Arial"/>
                 <a:cs typeface="Arial"/>
               </a:rPr>
-              <a:t>El histograma presenta 1.470 puntuaciones OOF de la regresión logística agrupadas en intervalos de una décima. No son probabilidades calibradas.</a:t>
+              <a:t>El histograma agrupa 1.470 puntuaciones OOF de Regresión Logística en intervalos de 0,10; 773 valores (52,6 %) quedan por debajo de 0,30.</a:t>
             </a:r>
             <a:endParaRPr sz="2000" b="0" u="none">
               <a:solidFill>
@@ -851,7 +851,7 @@
                 <a:ea typeface="Arial"/>
                 <a:cs typeface="Arial"/>
               </a:rPr>
-              <a:t>Ventas presenta 20,6 % de rotación observada, Recursos Humanos 19,0 % e Investigación y Desarrollo 13,8 %. Los porcentajes son descriptivos del conjunto de ejemplo.</a:t>
+              <a:t>El gráfico compara las tasas observadas por departamento: Ventas 20,6 % (92/446), Recursos Humanos 19,0 % (12/63) e Investigación y Desarrollo 13,8 % (133/961).</a:t>
             </a:r>
             <a:endParaRPr sz="2000" b="0" u="none">
               <a:solidFill>
@@ -943,7 +943,7 @@
                 <a:ea typeface="Arial"/>
                 <a:cs typeface="Arial"/>
               </a:rPr>
-              <a:t>La tasa observada es 30,5 % entre los registros con horas extra y 10,4 % entre los registros sin ellas. Esta comparación no demuestra causalidad.</a:t>
+              <a:t>La visualización contrasta la tasa observada con y sin horas extra. La diferencia orienta una revisión de turnos y distribución de carga.</a:t>
             </a:r>
             <a:endParaRPr sz="2000" b="0" u="none">
               <a:solidFill>
@@ -1035,7 +1035,7 @@
                 <a:ea typeface="Arial"/>
                 <a:cs typeface="Arial"/>
               </a:rPr>
-              <a:t>Los coeficientes proceden de la regresión logística ajustada sobre todas las filas tras evaluar el protocolo OOF. Señalan asociaciones aprendidas por el modelo, no causas.</a:t>
+              <a:t>Entre los coeficientes de mayor magnitud figuran representante de ventas (+1,070), viajes frecuentes (+0,856) y director/a de investigación (−1,121). Estos valores ayudan a concretar preguntas para los responsables de cada área.</a:t>
             </a:r>
             <a:endParaRPr sz="2000" b="0" u="none">
               <a:solidFill>
@@ -1127,7 +1127,7 @@
                 <a:ea typeface="Arial"/>
                 <a:cs typeface="Arial"/>
               </a:rPr>
-              <a:t>La regresión logística obtiene la mejor ROC-AUC y PR-AUC; el bosque aleatorio logra el mayor F1 con umbral ajustado. La encuesta es sintética y no hay validación independiente, temporal ni formal de equidad.</a:t>
+              <a:t>Regresión Logística ordena mejor por ROC-AUC (0,819) y PR-AUC (0,552); Random Forest alcanza el mayor F1 (0,544). Al umbral comparativo 0,732, las predicciones OOF de Regresión Logística reúnen 228 señales: 104 en Ventas, 115 en I+D y 9 en RR. HH. Se propone revisar primero Ventas por tasa y, en paralelo, I+D por volumen; después, seguir la evolución de horas extra, equipos y áreas tras cada acción.</a:t>
             </a:r>
             <a:endParaRPr sz="2000" b="0" u="none">
               <a:solidFill>
@@ -7446,17 +7446,17 @@
   </p:cSld>
   <p:clrMap bg1="lt1" tx1="dk1" bg2="lt2" tx2="dk2" accent1="accent1" accent2="accent2" accent3="accent3" accent4="accent4" accent5="accent5" accent6="accent6" hlink="hlink" folHlink="folHlink"/>
   <p:sldLayoutIdLst>
-    <p:sldLayoutId xmlns:r="http://schemas.openxmlformats.org/officeDocument/2006/relationships" id="2147483649" r:id="Rf6b1593467df4341"/>
-    <p:sldLayoutId xmlns:r="http://schemas.openxmlformats.org/officeDocument/2006/relationships" id="2147483650" r:id="R8b9d5e5eea924506"/>
-    <p:sldLayoutId xmlns:r="http://schemas.openxmlformats.org/officeDocument/2006/relationships" id="2147483651" r:id="R67e66f92f29f49d7"/>
-    <p:sldLayoutId xmlns:r="http://schemas.openxmlformats.org/officeDocument/2006/relationships" id="2147483652" r:id="R632aeb6ef9724666"/>
-    <p:sldLayoutId xmlns:r="http://schemas.openxmlformats.org/officeDocument/2006/relationships" id="2147483653" r:id="Rb6fb23d826b44560"/>
-    <p:sldLayoutId xmlns:r="http://schemas.openxmlformats.org/officeDocument/2006/relationships" id="2147483654" r:id="Rd1342649fad7472c"/>
-    <p:sldLayoutId xmlns:r="http://schemas.openxmlformats.org/officeDocument/2006/relationships" id="2147483655" r:id="R3eefeb29993a4111"/>
-    <p:sldLayoutId xmlns:r="http://schemas.openxmlformats.org/officeDocument/2006/relationships" id="2147483656" r:id="R76147fd507ab458c"/>
-    <p:sldLayoutId xmlns:r="http://schemas.openxmlformats.org/officeDocument/2006/relationships" id="2147483657" r:id="R0e6cd6c6e20846d4"/>
-    <p:sldLayoutId xmlns:r="http://schemas.openxmlformats.org/officeDocument/2006/relationships" id="2147483658" r:id="Rc80ca6e7bae14c1b"/>
-    <p:sldLayoutId xmlns:r="http://schemas.openxmlformats.org/officeDocument/2006/relationships" id="2147483659" r:id="R54b4a39efdf24a6c"/>
+    <p:sldLayoutId xmlns:r="http://schemas.openxmlformats.org/officeDocument/2006/relationships" id="2147483649" r:id="R62f87b36fef6416b"/>
+    <p:sldLayoutId xmlns:r="http://schemas.openxmlformats.org/officeDocument/2006/relationships" id="2147483650" r:id="Rc4cd25f3daf54f4a"/>
+    <p:sldLayoutId xmlns:r="http://schemas.openxmlformats.org/officeDocument/2006/relationships" id="2147483651" r:id="R5bbc6de49a884299"/>
+    <p:sldLayoutId xmlns:r="http://schemas.openxmlformats.org/officeDocument/2006/relationships" id="2147483652" r:id="Re9f1425394f34951"/>
+    <p:sldLayoutId xmlns:r="http://schemas.openxmlformats.org/officeDocument/2006/relationships" id="2147483653" r:id="Ra7ed604cde7743bf"/>
+    <p:sldLayoutId xmlns:r="http://schemas.openxmlformats.org/officeDocument/2006/relationships" id="2147483654" r:id="R171c142947af4e12"/>
+    <p:sldLayoutId xmlns:r="http://schemas.openxmlformats.org/officeDocument/2006/relationships" id="2147483655" r:id="R5ba67c35d22e4dfa"/>
+    <p:sldLayoutId xmlns:r="http://schemas.openxmlformats.org/officeDocument/2006/relationships" id="2147483656" r:id="R445be5b39fd5409b"/>
+    <p:sldLayoutId xmlns:r="http://schemas.openxmlformats.org/officeDocument/2006/relationships" id="2147483657" r:id="R3347ad588d80473b"/>
+    <p:sldLayoutId xmlns:r="http://schemas.openxmlformats.org/officeDocument/2006/relationships" id="2147483658" r:id="R0c49642d028641a5"/>
+    <p:sldLayoutId xmlns:r="http://schemas.openxmlformats.org/officeDocument/2006/relationships" id="2147483659" r:id="R1a0587eab43948ca"/>
   </p:sldLayoutIdLst>
 </p:sldMaster>
 </file>
@@ -7660,7 +7660,7 @@
                 <c:v>Regresión logística</c:v>
               </c:pt>
               <c:pt idx="1">
-                <c:v>Bosque aleatorio</c:v>
+                <c:v>Random Forest</c:v>
               </c:pt>
               <c:pt idx="2">
                 <c:v>Red neuronal MLP</c:v>
@@ -7701,7 +7701,7 @@
                 <c:v>Regresión logística</c:v>
               </c:pt>
               <c:pt idx="1">
-                <c:v>Bosque aleatorio</c:v>
+                <c:v>Random Forest</c:v>
               </c:pt>
               <c:pt idx="2">
                 <c:v>Red neuronal MLP</c:v>
@@ -7742,7 +7742,7 @@
                 <c:v>Regresión logística</c:v>
               </c:pt>
               <c:pt idx="1">
-                <c:v>Bosque aleatorio</c:v>
+                <c:v>Random Forest</c:v>
               </c:pt>
               <c:pt idx="2">
                 <c:v>Red neuronal MLP</c:v>
@@ -8968,7 +8968,7 @@
                 <a:ea typeface="Calibri"/>
                 <a:cs typeface="Calibri"/>
               </a:rPr>
-              <a:t>Proyecto educativo · PySpark · aprendizaje automático · Power BI</a:t>
+              <a:t>Proyecto educativo · Big Data · PySpark · aprendizaje automático · Power BI</a:t>
             </a:r>
             <a:endParaRPr sz="3200" b="0" u="none">
               <a:solidFill>
@@ -9123,7 +9123,7 @@
                 <a:ea typeface="Calibri"/>
                 <a:cs typeface="Calibri"/>
               </a:rPr>
-              <a:t>Ejercicio académico de clasificación con datos de ejemplo.</a:t>
+              <a:t>Clasificación de Attrition y preparación de datos con PySpark.</a:t>
             </a:r>
             <a:endParaRPr sz="3200" b="0" u="none">
               <a:solidFill>
@@ -9157,7 +9157,7 @@
                 <a:ea typeface="Calibri"/>
                 <a:cs typeface="Calibri"/>
               </a:rPr>
-              <a:t>Preparación de datos con PySpark y modelos con scikit-learn.</a:t>
+              <a:t>Comparación de Regresión Logística, Random Forest y MLP.</a:t>
             </a:r>
             <a:endParaRPr sz="3200" b="0" u="none">
               <a:solidFill>
@@ -9191,7 +9191,7 @@
                 <a:ea typeface="Calibri"/>
                 <a:cs typeface="Calibri"/>
               </a:rPr>
-              <a:t>Comparación de regresión logística, bosque aleatorio y red neuronal MLP.</a:t>
+              <a:t>Validación cruzada estratificada en cinco particiones.</a:t>
             </a:r>
             <a:endParaRPr sz="3200" b="0" u="none">
               <a:solidFill>
@@ -9225,7 +9225,7 @@
                 <a:ea typeface="Calibri"/>
                 <a:cs typeface="Calibri"/>
               </a:rPr>
-              <a:t>Evaluación con validación cruzada estratificada de cinco particiones.</a:t>
+              <a:t>Lectura de métricas y puntuaciones por departamento y variables laborales.</a:t>
             </a:r>
             <a:endParaRPr sz="3200" b="0" u="none">
               <a:solidFill>
@@ -9259,41 +9259,7 @@
                 <a:ea typeface="Calibri"/>
                 <a:cs typeface="Calibri"/>
               </a:rPr>
-              <a:t>Análisis descriptivo y prototipo de panel de control en Power BI.</a:t>
-            </a:r>
-            <a:endParaRPr sz="3200" b="0" u="none">
-              <a:solidFill>
-                <a:schemeClr val="dk1"/>
-              </a:solidFill>
-              <a:latin typeface="Calibri"/>
-              <a:ea typeface="Calibri"/>
-              <a:cs typeface="Calibri"/>
-            </a:endParaRPr>
-          </a:p>
-          <a:p xmlns:a="http://schemas.openxmlformats.org/drawingml/2006/main">
-            <a:pPr marL="343080" indent="-343080" defTabSz="457200">
-              <a:lnSpc>
-                <a:spcPct val="100000"/>
-              </a:lnSpc>
-              <a:spcBef>
-                <a:spcPts val="641"/>
-              </a:spcBef>
-              <a:buClr>
-                <a:srgbClr val="000000"/>
-              </a:buClr>
-              <a:buFont typeface="Arial"/>
-              <a:buChar char="•"/>
-            </a:pPr>
-            <a:r>
-              <a:rPr sz="3200" b="0" u="none">
-                <a:solidFill>
-                  <a:schemeClr val="dk1"/>
-                </a:solidFill>
-                <a:latin typeface="Calibri"/>
-                <a:ea typeface="Calibri"/>
-                <a:cs typeface="Calibri"/>
-              </a:rPr>
-              <a:t>Resultados exploratorios, sin uso operativo sobre personas.</a:t>
+              <a:t>Recomendaciones para priorizar diagnósticos y acciones de retención.</a:t>
             </a:r>
             <a:endParaRPr sz="3200" b="0" u="none">
               <a:solidFill>
@@ -9448,7 +9414,7 @@
                 <a:ea typeface="Calibri"/>
                 <a:cs typeface="Calibri"/>
               </a:rPr>
-              <a:t>Comprobar la calidad de las claves y los datos de entrada.</a:t>
+              <a:t>Comprobar la calidad de claves y datos de entrada.</a:t>
             </a:r>
             <a:endParaRPr sz="3200" b="0" u="none">
               <a:solidFill>
@@ -9482,7 +9448,7 @@
                 <a:ea typeface="Calibri"/>
                 <a:cs typeface="Calibri"/>
               </a:rPr>
-              <a:t>Generar la encuesta sintética con semilla fija y unirla al conjunto principal.</a:t>
+              <a:t>Generar la encuesta con semilla fija e integrarla mediante EmployeeNumber.</a:t>
             </a:r>
             <a:endParaRPr sz="3200" b="0" u="none">
               <a:solidFill>
@@ -9550,7 +9516,7 @@
                 <a:ea typeface="Calibri"/>
                 <a:cs typeface="Calibri"/>
               </a:rPr>
-              <a:t>Entrenar tres modelos con variables numéricas y categóricas preparadas.</a:t>
+              <a:t>Entrenar tres modelos con variables numéricas y categóricas.</a:t>
             </a:r>
             <a:endParaRPr sz="3200" b="0" u="none">
               <a:solidFill>
@@ -9584,7 +9550,7 @@
                 <a:ea typeface="Calibri"/>
                 <a:cs typeface="Calibri"/>
               </a:rPr>
-              <a:t>Comparar predicciones fuera de muestra y exportar métricas y gráficos.</a:t>
+              <a:t>Relacionar métricas, tasas y puntuaciones con prioridades por área.</a:t>
             </a:r>
             <a:endParaRPr sz="3200" b="0" u="none">
               <a:solidFill>
@@ -9736,7 +9702,7 @@
                 <a:ea typeface="Calibri"/>
                 <a:cs typeface="Calibri"/>
               </a:rPr>
-              <a:t>Validación cruzada de cinco particiones. F1 y umbral se ajustaron con las mismas predicciones y son resultados exploratorios.</a:t>
+              <a:t>La gráfica compara ROC-AUC, PR-AUC y F1: Regresión Logística lidera ROC/PR; Random Forest, F1.</a:t>
             </a:r>
             <a:endParaRPr sz="1400" b="0" u="none">
               <a:solidFill>
@@ -9754,7 +9720,7 @@
           <p:cNvPr id="75" name="Fondo gráfico 4">
             <a:extLst>
               <a:ext uri="{FF2B5EF4-FFF2-40B4-BE49-F238E27FC236}">
-                <ns2:creationId id="{503B5F3B-E333-4FD6-8469-1460423105A7}"/>
+                <ns2:creationId id="{531909E2-0426-4DFE-AFD7-AAA0EA1C435C}"/>
               </a:ext>
             </a:extLst>
           </p:cNvPr>
@@ -9793,7 +9759,7 @@
         </p:xfrm>
         <a:graphic>
           <a:graphicData uri="http://schemas.openxmlformats.org/drawingml/2006/chart">
-            <ns3:chart r:id="Re8af452dc3cf4eec"/>
+            <ns3:chart r:id="Rfadd2ec3d2154f88"/>
           </a:graphicData>
         </a:graphic>
       </p:graphicFrame>
@@ -9936,7 +9902,7 @@
                 <a:ea typeface="Calibri"/>
                 <a:cs typeface="Calibri"/>
               </a:rPr>
-              <a:t>Se agrupan 1.470 puntuaciones en intervalos de 0,10. La mayoría queda por debajo de 0,30; no son probabilidades calibradas.</a:t>
+              <a:t>Las 1.470 puntuaciones OOF se agrupan en intervalos de 0,10; 773 quedan por debajo de 0,30.</a:t>
             </a:r>
             <a:endParaRPr sz="1400" b="0" u="none">
               <a:solidFill>
@@ -9954,7 +9920,7 @@
           <p:cNvPr id="78" name="Fondo gráfico 5">
             <a:extLst>
               <a:ext uri="{FF2B5EF4-FFF2-40B4-BE49-F238E27FC236}">
-                <ns2:creationId id="{DC35DDDA-ABAD-4D4F-9348-1AC0211A76CC}"/>
+                <ns2:creationId id="{159EFCAB-93CF-4983-AD99-0D5D834EFD96}"/>
               </a:ext>
             </a:extLst>
           </p:cNvPr>
@@ -9993,7 +9959,7 @@
         </p:xfrm>
         <a:graphic>
           <a:graphicData uri="http://schemas.openxmlformats.org/drawingml/2006/chart">
-            <ns3:chart r:id="R54aaff37545d491c"/>
+            <ns3:chart r:id="R8c303e39f5214024"/>
           </a:graphicData>
         </a:graphic>
       </p:graphicFrame>
@@ -10136,7 +10102,7 @@
                 <a:ea typeface="Calibri"/>
                 <a:cs typeface="Calibri"/>
               </a:rPr>
-              <a:t>Ventas: 20,6 %; Recursos Humanos: 19,0 %; Investigación y Desarrollo: 13,8 %. Ventas muestra la tasa más alta.</a:t>
+              <a:t>Ventas registra 20,6 % (92/446), RR. HH. 19,0 % (12/63) e I+D 13,8 % (133/961).</a:t>
             </a:r>
             <a:endParaRPr sz="1400" b="0" u="none">
               <a:solidFill>
@@ -10154,7 +10120,7 @@
           <p:cNvPr id="81" name="Fondo gráfico 6">
             <a:extLst>
               <a:ext uri="{FF2B5EF4-FFF2-40B4-BE49-F238E27FC236}">
-                <ns2:creationId id="{A034AD31-AC6E-4576-B0E1-6EC203D36773}"/>
+                <ns2:creationId id="{00442256-553E-4777-B321-F210439A2046}"/>
               </a:ext>
             </a:extLst>
           </p:cNvPr>
@@ -10193,7 +10159,7 @@
         </p:xfrm>
         <a:graphic>
           <a:graphicData uri="http://schemas.openxmlformats.org/drawingml/2006/chart">
-            <ns3:chart r:id="Rb809e15e7cf34f13"/>
+            <ns3:chart r:id="R49f36148a9104bfa"/>
           </a:graphicData>
         </a:graphic>
       </p:graphicFrame>
@@ -10336,7 +10302,7 @@
                 <a:ea typeface="Calibri"/>
                 <a:cs typeface="Calibri"/>
               </a:rPr>
-              <a:t>30,5 % con horas extra (127/416), frente a 10,4 % sin ellas (110/1.054). Es una asociación observada, no causal.</a:t>
+              <a:t>Rotación observada: 30,5 % con horas extra (127/416) y 10,4 % sin ellas (110/1.054).</a:t>
             </a:r>
             <a:endParaRPr sz="1400" b="0" u="none">
               <a:solidFill>
@@ -10354,7 +10320,7 @@
           <p:cNvPr id="84" name="Fondo gráfico 7">
             <a:extLst>
               <a:ext uri="{FF2B5EF4-FFF2-40B4-BE49-F238E27FC236}">
-                <ns2:creationId id="{39CE3FF9-2A38-4BD6-92B9-657BE1A25632}"/>
+                <ns2:creationId id="{070F6796-76D7-4070-820D-83D2D0095841}"/>
               </a:ext>
             </a:extLst>
           </p:cNvPr>
@@ -10393,7 +10359,7 @@
         </p:xfrm>
         <a:graphic>
           <a:graphicData uri="http://schemas.openxmlformats.org/drawingml/2006/chart">
-            <ns3:chart r:id="Rde3ba51aefa948e2"/>
+            <ns3:chart r:id="R012aa23211094245"/>
           </a:graphicData>
         </a:graphic>
       </p:graphicFrame>
@@ -10536,7 +10502,7 @@
                 <a:ea typeface="Calibri"/>
                 <a:cs typeface="Calibri"/>
               </a:rPr>
-              <a:t>El signo (+/−) indica la dirección del coeficiente. La magnitud refleja una asociación del modelo, no un efecto causal.</a:t>
+              <a:t>Representante de ventas (+1,070) y viajes frecuentes (+0,856) destacan entre las señales asociadas del modelo.</a:t>
             </a:r>
             <a:endParaRPr sz="1400" b="0" u="none">
               <a:solidFill>
@@ -10554,7 +10520,7 @@
           <p:cNvPr id="87" name="Fondo gráfico 8">
             <a:extLst>
               <a:ext uri="{FF2B5EF4-FFF2-40B4-BE49-F238E27FC236}">
-                <ns2:creationId id="{3A2496CE-6E9F-4F99-86F3-6564146FBB94}"/>
+                <ns2:creationId id="{09819C8A-8FE9-4AF3-8A81-CA1D404C8F58}"/>
               </a:ext>
             </a:extLst>
           </p:cNvPr>
@@ -10593,7 +10559,7 @@
         </p:xfrm>
         <a:graphic>
           <a:graphicData uri="http://schemas.openxmlformats.org/drawingml/2006/chart">
-            <ns3:chart r:id="Rfd7fc54d2a2d44b8"/>
+            <ns3:chart r:id="R260bb3c1307744be"/>
           </a:graphicData>
         </a:graphic>
       </p:graphicFrame>
@@ -10669,7 +10635,7 @@
                 <a:ea typeface="Calibri"/>
                 <a:cs typeface="Calibri"/>
               </a:rPr>
-              <a:t>Resultados, conclusiones y límites</a:t>
+              <a:t>Conclusiones y prioridades para dirección</a:t>
             </a:r>
             <a:endParaRPr sz="4400" b="0" u="none">
               <a:solidFill>
@@ -10739,7 +10705,7 @@
                 <a:ea typeface="Calibri"/>
                 <a:cs typeface="Calibri"/>
               </a:rPr>
-              <a:t>Regresión logística: mejor ROC-AUC (0,819) y PR-AUC (0,552).</a:t>
+              <a:t>Regresión Logística: ROC/PR 0,819/0,552; Random Forest, F1 0,544.</a:t>
             </a:r>
             <a:endParaRPr sz="3200" b="0" u="none">
               <a:solidFill>
@@ -10773,7 +10739,7 @@
                 <a:ea typeface="Calibri"/>
                 <a:cs typeface="Calibri"/>
               </a:rPr>
-              <a:t>Bosque aleatorio: mayor F1 ajustado (0,544; umbral 0,210).</a:t>
+              <a:t>Ventas: 20,6 % (92/446), 104 señales. Revisar viajes, objetivos y carga.</a:t>
             </a:r>
             <a:endParaRPr sz="3200" b="0" u="none">
               <a:solidFill>
@@ -10807,7 +10773,7 @@
                 <a:ea typeface="Calibri"/>
                 <a:cs typeface="Calibri"/>
               </a:rPr>
-              <a:t>MLP: ROC-AUC 0,768 y PR-AUC 0,484, los valores más bajos.</a:t>
+              <a:t>I+D: 115 señales y 133 salidas; priorizar equipos y puestos.</a:t>
             </a:r>
             <a:endParaRPr sz="3200" b="0" u="none">
               <a:solidFill>
@@ -10841,7 +10807,7 @@
                 <a:ea typeface="Calibri"/>
                 <a:cs typeface="Calibri"/>
               </a:rPr>
-              <a:t>La encuesta sintética no aporta evidencia sobre empleados reales.</a:t>
+              <a:t>Horas extra: 30,5 % vs. 10,4 %. Revisar turnos y carga.</a:t>
             </a:r>
             <a:endParaRPr sz="3200" b="0" u="none">
               <a:solidFill>
@@ -10875,7 +10841,7 @@
                 <a:ea typeface="Calibri"/>
                 <a:cs typeface="Calibri"/>
               </a:rPr>
-              <a:t>Conclusión: flujo educativo, sin validación para decisiones laborales.</a:t>
+              <a:t>RR. HH.: 19 % (12/63), 9 señales. Medir antes y después.</a:t>
             </a:r>
             <a:endParaRPr sz="3200" b="0" u="none">
               <a:solidFill>

</xml_diff>

<commit_message>
Refine business recommendations and project materials
</commit_message>
<xml_diff>
--- a/docs/Presentacion_Proyecto_Rotacion.pptx
+++ b/docs/Presentacion_Proyecto_Rotacion.pptx
@@ -2,21 +2,21 @@
 <file path=ppt/presentation.xml><?xml version="1.0" encoding="utf-8"?>
 <p:presentation xmlns:p="http://schemas.openxmlformats.org/presentationml/2006/main">
   <p:sldMasterIdLst>
-    <p:sldMasterId xmlns:r="http://schemas.openxmlformats.org/officeDocument/2006/relationships" id="2147483648" r:id="R446f805d99dd44ba"/>
+    <p:sldMasterId xmlns:r="http://schemas.openxmlformats.org/officeDocument/2006/relationships" id="2147483648" r:id="R8734ef3098554efb"/>
   </p:sldMasterIdLst>
   <p:notesMasterIdLst>
-    <p:notesMasterId xmlns:r="http://schemas.openxmlformats.org/officeDocument/2006/relationships" r:id="R97a8917883244c87"/>
+    <p:notesMasterId xmlns:r="http://schemas.openxmlformats.org/officeDocument/2006/relationships" r:id="Rf84322a769e74caa"/>
   </p:notesMasterIdLst>
   <p:sldIdLst>
-    <p:sldId xmlns:r="http://schemas.openxmlformats.org/officeDocument/2006/relationships" id="256" r:id="R82b0342d2bf34755"/>
-    <p:sldId xmlns:r="http://schemas.openxmlformats.org/officeDocument/2006/relationships" id="257" r:id="R33dd6ffded5a42a0"/>
-    <p:sldId xmlns:r="http://schemas.openxmlformats.org/officeDocument/2006/relationships" id="258" r:id="R7f55d0d02f6a4c39"/>
-    <p:sldId xmlns:r="http://schemas.openxmlformats.org/officeDocument/2006/relationships" id="259" r:id="R373c1dfa4e51492c"/>
-    <p:sldId xmlns:r="http://schemas.openxmlformats.org/officeDocument/2006/relationships" id="260" r:id="R294ef80b0e8845fb"/>
-    <p:sldId xmlns:r="http://schemas.openxmlformats.org/officeDocument/2006/relationships" id="261" r:id="R9358700a9b0641c8"/>
-    <p:sldId xmlns:r="http://schemas.openxmlformats.org/officeDocument/2006/relationships" id="262" r:id="R54c7b98f49a74c46"/>
-    <p:sldId xmlns:r="http://schemas.openxmlformats.org/officeDocument/2006/relationships" id="263" r:id="Rf8982be3a5ce4b12"/>
-    <p:sldId xmlns:r="http://schemas.openxmlformats.org/officeDocument/2006/relationships" id="264" r:id="Rfd597fcd62ef470c"/>
+    <p:sldId xmlns:r="http://schemas.openxmlformats.org/officeDocument/2006/relationships" id="256" r:id="R52cbed1790c545e2"/>
+    <p:sldId xmlns:r="http://schemas.openxmlformats.org/officeDocument/2006/relationships" id="257" r:id="R81ee4facf8a1446b"/>
+    <p:sldId xmlns:r="http://schemas.openxmlformats.org/officeDocument/2006/relationships" id="258" r:id="Ref06223ce62f42e6"/>
+    <p:sldId xmlns:r="http://schemas.openxmlformats.org/officeDocument/2006/relationships" id="259" r:id="R8da7394057eb438c"/>
+    <p:sldId xmlns:r="http://schemas.openxmlformats.org/officeDocument/2006/relationships" id="260" r:id="R42d037dfdde34563"/>
+    <p:sldId xmlns:r="http://schemas.openxmlformats.org/officeDocument/2006/relationships" id="261" r:id="R5f5eb6597f0d4ea7"/>
+    <p:sldId xmlns:r="http://schemas.openxmlformats.org/officeDocument/2006/relationships" id="262" r:id="R9e2af8bc6ce44a79"/>
+    <p:sldId xmlns:r="http://schemas.openxmlformats.org/officeDocument/2006/relationships" id="263" r:id="Rd3b2df5f4902462c"/>
+    <p:sldId xmlns:r="http://schemas.openxmlformats.org/officeDocument/2006/relationships" id="264" r:id="Rc3f2d4da47b9402e"/>
   </p:sldIdLst>
   <p:sldSz cx="12192000" cy="6858000"/>
   <p:notesSz cx="6858000" cy="9144000"/>
@@ -7446,17 +7446,17 @@
   </p:cSld>
   <p:clrMap bg1="lt1" tx1="dk1" bg2="lt2" tx2="dk2" accent1="accent1" accent2="accent2" accent3="accent3" accent4="accent4" accent5="accent5" accent6="accent6" hlink="hlink" folHlink="folHlink"/>
   <p:sldLayoutIdLst>
-    <p:sldLayoutId xmlns:r="http://schemas.openxmlformats.org/officeDocument/2006/relationships" id="2147483649" r:id="R62f87b36fef6416b"/>
-    <p:sldLayoutId xmlns:r="http://schemas.openxmlformats.org/officeDocument/2006/relationships" id="2147483650" r:id="Rc4cd25f3daf54f4a"/>
-    <p:sldLayoutId xmlns:r="http://schemas.openxmlformats.org/officeDocument/2006/relationships" id="2147483651" r:id="R5bbc6de49a884299"/>
-    <p:sldLayoutId xmlns:r="http://schemas.openxmlformats.org/officeDocument/2006/relationships" id="2147483652" r:id="Re9f1425394f34951"/>
-    <p:sldLayoutId xmlns:r="http://schemas.openxmlformats.org/officeDocument/2006/relationships" id="2147483653" r:id="Ra7ed604cde7743bf"/>
-    <p:sldLayoutId xmlns:r="http://schemas.openxmlformats.org/officeDocument/2006/relationships" id="2147483654" r:id="R171c142947af4e12"/>
-    <p:sldLayoutId xmlns:r="http://schemas.openxmlformats.org/officeDocument/2006/relationships" id="2147483655" r:id="R5ba67c35d22e4dfa"/>
-    <p:sldLayoutId xmlns:r="http://schemas.openxmlformats.org/officeDocument/2006/relationships" id="2147483656" r:id="R445be5b39fd5409b"/>
-    <p:sldLayoutId xmlns:r="http://schemas.openxmlformats.org/officeDocument/2006/relationships" id="2147483657" r:id="R3347ad588d80473b"/>
-    <p:sldLayoutId xmlns:r="http://schemas.openxmlformats.org/officeDocument/2006/relationships" id="2147483658" r:id="R0c49642d028641a5"/>
-    <p:sldLayoutId xmlns:r="http://schemas.openxmlformats.org/officeDocument/2006/relationships" id="2147483659" r:id="R1a0587eab43948ca"/>
+    <p:sldLayoutId xmlns:r="http://schemas.openxmlformats.org/officeDocument/2006/relationships" id="2147483649" r:id="Rbd630cd014ae4417"/>
+    <p:sldLayoutId xmlns:r="http://schemas.openxmlformats.org/officeDocument/2006/relationships" id="2147483650" r:id="R2541562be58342d8"/>
+    <p:sldLayoutId xmlns:r="http://schemas.openxmlformats.org/officeDocument/2006/relationships" id="2147483651" r:id="Rf6dc6488ce0e4d8b"/>
+    <p:sldLayoutId xmlns:r="http://schemas.openxmlformats.org/officeDocument/2006/relationships" id="2147483652" r:id="Rdef2c08b885b4d0d"/>
+    <p:sldLayoutId xmlns:r="http://schemas.openxmlformats.org/officeDocument/2006/relationships" id="2147483653" r:id="R608ad6dc14bc4406"/>
+    <p:sldLayoutId xmlns:r="http://schemas.openxmlformats.org/officeDocument/2006/relationships" id="2147483654" r:id="R1ab5792f403d4050"/>
+    <p:sldLayoutId xmlns:r="http://schemas.openxmlformats.org/officeDocument/2006/relationships" id="2147483655" r:id="R90110a8734bc465e"/>
+    <p:sldLayoutId xmlns:r="http://schemas.openxmlformats.org/officeDocument/2006/relationships" id="2147483656" r:id="R29d2513a639a4751"/>
+    <p:sldLayoutId xmlns:r="http://schemas.openxmlformats.org/officeDocument/2006/relationships" id="2147483657" r:id="R9fc13524e5344fa5"/>
+    <p:sldLayoutId xmlns:r="http://schemas.openxmlformats.org/officeDocument/2006/relationships" id="2147483658" r:id="Rb9c3a17bfe3742da"/>
+    <p:sldLayoutId xmlns:r="http://schemas.openxmlformats.org/officeDocument/2006/relationships" id="2147483659" r:id="R850f0d452acc46bf"/>
   </p:sldLayoutIdLst>
 </p:sldMaster>
 </file>
@@ -9574,7 +9574,7 @@
 </file>
 
 <file path=ppt/slides/slide4.xml><?xml version="1.0" encoding="utf-8"?>
-<p:sld xmlns:a="http://schemas.openxmlformats.org/drawingml/2006/main" xmlns:ns2="http://schemas.microsoft.com/office/drawing/2014/main" xmlns:ns3="http://schemas.openxmlformats.org/drawingml/2006/chart" xmlns:ns5="http://schemas.microsoft.com/office/powerpoint/2010/main" xmlns:p="http://schemas.openxmlformats.org/presentationml/2006/main" xmlns:r="http://schemas.openxmlformats.org/officeDocument/2006/relationships">
+<p:sld xmlns:p="http://schemas.openxmlformats.org/presentationml/2006/main">
   <p:cSld>
     <p:spTree>
       <p:nvGrpSpPr>
@@ -9583,43 +9583,43 @@
         <p:nvPr/>
       </p:nvGrpSpPr>
       <p:grpSpPr>
-        <a:xfrm/>
+        <a:xfrm xmlns:a="http://schemas.openxmlformats.org/drawingml/2006/main"/>
       </p:grpSpPr>
       <p:sp>
         <p:nvSpPr>
           <p:cNvPr id="71" name="PlaceHolder 1">
-            <a:extLst>
+            <a:extLst xmlns:a="http://schemas.openxmlformats.org/drawingml/2006/main">
               <a:ext uri="{FF2B5EF4-FFF2-40B4-BE49-F238E27FC236}">
-                <ns2:creationId id="{65E0130A-3CA4-4060-A9FD-904D0A35ECFA}"/>
+                <a16:creationId xmlns:a16="http://schemas.microsoft.com/office/drawing/2014/main" id="{65E0130A-3CA4-4060-A9FD-904D0A35ECFA}"/>
               </a:ext>
             </a:extLst>
           </p:cNvPr>
           <p:cNvSpPr>
-            <a:spLocks noGrp="1"/>
+            <a:spLocks xmlns:a="http://schemas.openxmlformats.org/drawingml/2006/main" noGrp="1"/>
           </p:cNvSpPr>
           <p:nvPr>
             <p:ph type="title" idx="0"/>
           </p:nvPr>
         </p:nvSpPr>
         <p:spPr>
-          <a:xfrm>
+          <a:xfrm xmlns:a="http://schemas.openxmlformats.org/drawingml/2006/main">
             <a:off x="1620000" y="117360"/>
             <a:ext cx="8229240" cy="1142640"/>
           </a:xfrm>
-          <a:prstGeom prst="rect">
+          <a:prstGeom xmlns:a="http://schemas.openxmlformats.org/drawingml/2006/main" prst="rect">
             <a:avLst/>
           </a:prstGeom>
-          <a:noFill/>
-          <a:ln w="0">
+          <a:noFill xmlns:a="http://schemas.openxmlformats.org/drawingml/2006/main"/>
+          <a:ln xmlns:a="http://schemas.openxmlformats.org/drawingml/2006/main" w="0">
             <a:noFill/>
           </a:ln>
         </p:spPr>
         <p:txBody>
-          <a:bodyPr lIns="91440" tIns="45720" rIns="91440" bIns="45720" anchor="ctr">
+          <a:bodyPr xmlns:a="http://schemas.openxmlformats.org/drawingml/2006/main" lIns="91440" tIns="45720" rIns="91440" bIns="45720" anchor="ctr">
             <a:noAutofit/>
           </a:bodyPr>
-          <a:lstStyle/>
-          <a:p>
+          <a:lstStyle xmlns:a="http://schemas.openxmlformats.org/drawingml/2006/main"/>
+          <a:p xmlns:a="http://schemas.openxmlformats.org/drawingml/2006/main">
             <a:pPr indent="0" algn="ctr" defTabSz="457200">
               <a:lnSpc>
                 <a:spcPct val="100000"/>
@@ -9651,42 +9651,42 @@
       <p:sp>
         <p:nvSpPr>
           <p:cNvPr id="73" name="TextBox 3">
-            <a:extLst>
+            <a:extLst xmlns:a="http://schemas.openxmlformats.org/drawingml/2006/main">
               <a:ext uri="{FF2B5EF4-FFF2-40B4-BE49-F238E27FC236}">
-                <ns2:creationId id="{D179EA43-F748-45D7-9F30-071F40E196A0}"/>
+                <a16:creationId xmlns:a16="http://schemas.microsoft.com/office/drawing/2014/main" id="{D179EA43-F748-45D7-9F30-071F40E196A0}"/>
               </a:ext>
             </a:extLst>
           </p:cNvPr>
           <p:cNvSpPr>
-            <a:spLocks noGrp="1"/>
+            <a:spLocks xmlns:a="http://schemas.openxmlformats.org/drawingml/2006/main" noGrp="1"/>
           </p:cNvSpPr>
           <p:nvPr/>
         </p:nvSpPr>
         <p:spPr>
-          <a:xfrm>
+          <a:xfrm xmlns:a="http://schemas.openxmlformats.org/drawingml/2006/main">
             <a:off x="365760" y="6263640"/>
             <a:ext cx="11459880" cy="384048"/>
           </a:xfrm>
-          <a:prstGeom prst="rect">
+          <a:prstGeom xmlns:a="http://schemas.openxmlformats.org/drawingml/2006/main" prst="rect">
             <a:avLst/>
           </a:prstGeom>
-          <a:noFill/>
-          <a:ln w="0">
+          <a:noFill xmlns:a="http://schemas.openxmlformats.org/drawingml/2006/main"/>
+          <a:ln xmlns:a="http://schemas.openxmlformats.org/drawingml/2006/main" w="0">
             <a:noFill/>
           </a:ln>
         </p:spPr>
         <p:style>
-          <a:lnRef idx="0"/>
-          <a:fillRef idx="0"/>
-          <a:effectRef idx="0"/>
-          <a:fontRef idx="minor"/>
+          <a:lnRef xmlns:a="http://schemas.openxmlformats.org/drawingml/2006/main" idx="0"/>
+          <a:fillRef xmlns:a="http://schemas.openxmlformats.org/drawingml/2006/main" idx="0"/>
+          <a:effectRef xmlns:a="http://schemas.openxmlformats.org/drawingml/2006/main" idx="0"/>
+          <a:fontRef xmlns:a="http://schemas.openxmlformats.org/drawingml/2006/main" idx="minor"/>
         </p:style>
         <p:txBody>
-          <a:bodyPr wrap="none" lIns="90000" tIns="45000" rIns="90000" bIns="45000" anchor="t">
+          <a:bodyPr xmlns:a="http://schemas.openxmlformats.org/drawingml/2006/main" wrap="none" lIns="90000" tIns="45000" rIns="90000" bIns="45000" anchor="t">
             <a:spAutoFit/>
           </a:bodyPr>
-          <a:lstStyle/>
-          <a:p>
+          <a:lstStyle xmlns:a="http://schemas.openxmlformats.org/drawingml/2006/main"/>
+          <a:p xmlns:a="http://schemas.openxmlformats.org/drawingml/2006/main">
             <a:pPr algn="ctr" defTabSz="457200">
               <a:lnSpc>
                 <a:spcPct val="100000"/>
@@ -9718,29 +9718,29 @@
       <p:sp>
         <p:nvSpPr>
           <p:cNvPr id="75" name="Fondo gráfico 4">
-            <a:extLst>
+            <a:extLst xmlns:a="http://schemas.openxmlformats.org/drawingml/2006/main">
               <a:ext uri="{FF2B5EF4-FFF2-40B4-BE49-F238E27FC236}">
-                <ns2:creationId id="{531909E2-0426-4DFE-AFD7-AAA0EA1C435C}"/>
+                <a16:creationId xmlns:a16="http://schemas.microsoft.com/office/drawing/2014/main" id="{531909E2-0426-4DFE-AFD7-AAA0EA1C435C}"/>
               </a:ext>
             </a:extLst>
           </p:cNvPr>
           <p:cNvSpPr>
-            <a:spLocks noGrp="1"/>
+            <a:spLocks xmlns:a="http://schemas.openxmlformats.org/drawingml/2006/main" noGrp="1"/>
           </p:cNvSpPr>
           <p:nvPr/>
         </p:nvSpPr>
         <p:spPr>
-          <a:xfrm>
+          <a:xfrm xmlns:a="http://schemas.openxmlformats.org/drawingml/2006/main">
             <a:off x="2552700" y="952500"/>
             <a:ext cx="7086600" cy="5010150"/>
           </a:xfrm>
-          <a:prstGeom prst="rect">
+          <a:prstGeom xmlns:a="http://schemas.openxmlformats.org/drawingml/2006/main" prst="rect">
             <a:avLst/>
           </a:prstGeom>
-          <a:solidFill>
+          <a:solidFill xmlns:a="http://schemas.openxmlformats.org/drawingml/2006/main">
             <a:srgbClr val="FFFFFF"/>
           </a:solidFill>
-          <a:ln w="0">
+          <a:ln xmlns:a="http://schemas.openxmlformats.org/drawingml/2006/main" w="0">
             <a:solidFill>
               <a:srgbClr val="FFFFFF"/>
             </a:solidFill>
@@ -9749,24 +9749,24 @@
       </p:sp>
       <p:graphicFrame>
         <p:nvGraphicFramePr>
-          <p:cNvPr id="81" name="Chart"/>
+          <p:cNvPr id="80" name="Chart"/>
           <p:cNvGraphicFramePr/>
           <p:nvPr/>
         </p:nvGraphicFramePr>
         <p:xfrm>
-          <a:off x="2095500" y="1171575"/>
-          <a:ext cx="8001000" cy="4524375"/>
+          <a:off xmlns:a="http://schemas.openxmlformats.org/drawingml/2006/main" x="2095500" y="1171575"/>
+          <a:ext xmlns:a="http://schemas.openxmlformats.org/drawingml/2006/main" cx="8001000" cy="4524375"/>
         </p:xfrm>
-        <a:graphic>
+        <a:graphic xmlns:a="http://schemas.openxmlformats.org/drawingml/2006/main">
           <a:graphicData uri="http://schemas.openxmlformats.org/drawingml/2006/chart">
-            <ns3:chart r:id="Rfadd2ec3d2154f88"/>
+            <c:chart xmlns:r="http://schemas.openxmlformats.org/officeDocument/2006/relationships" xmlns:c="http://schemas.openxmlformats.org/drawingml/2006/chart" r:id="R7ba883996ff6444d"/>
           </a:graphicData>
         </a:graphic>
       </p:graphicFrame>
     </p:spTree>
     <p:extLst>
       <p:ext uri="{BB962C8B-B14F-4D97-AF65-F5344CB8AC3E}">
-        <ns5:creationId val="1507152452"/>
+        <p14:creationId xmlns:p14="http://schemas.microsoft.com/office/powerpoint/2010/main" val="1507152452"/>
       </p:ext>
     </p:extLst>
   </p:cSld>
@@ -9774,7 +9774,7 @@
 </file>
 
 <file path=ppt/slides/slide5.xml><?xml version="1.0" encoding="utf-8"?>
-<p:sld xmlns:a="http://schemas.openxmlformats.org/drawingml/2006/main" xmlns:ns2="http://schemas.microsoft.com/office/drawing/2014/main" xmlns:ns3="http://schemas.openxmlformats.org/drawingml/2006/chart" xmlns:ns5="http://schemas.microsoft.com/office/powerpoint/2010/main" xmlns:p="http://schemas.openxmlformats.org/presentationml/2006/main" xmlns:r="http://schemas.openxmlformats.org/officeDocument/2006/relationships">
+<p:sld xmlns:p="http://schemas.openxmlformats.org/presentationml/2006/main">
   <p:cSld>
     <p:spTree>
       <p:nvGrpSpPr>
@@ -9783,43 +9783,43 @@
         <p:nvPr/>
       </p:nvGrpSpPr>
       <p:grpSpPr>
-        <a:xfrm/>
+        <a:xfrm xmlns:a="http://schemas.openxmlformats.org/drawingml/2006/main"/>
       </p:grpSpPr>
       <p:sp>
         <p:nvSpPr>
           <p:cNvPr id="74" name="PlaceHolder 1">
-            <a:extLst>
+            <a:extLst xmlns:a="http://schemas.openxmlformats.org/drawingml/2006/main">
               <a:ext uri="{FF2B5EF4-FFF2-40B4-BE49-F238E27FC236}">
-                <ns2:creationId id="{2D52C905-F951-4F11-BF40-C3409FEC2BF8}"/>
+                <a16:creationId xmlns:a16="http://schemas.microsoft.com/office/drawing/2014/main" id="{2D52C905-F951-4F11-BF40-C3409FEC2BF8}"/>
               </a:ext>
             </a:extLst>
           </p:cNvPr>
           <p:cNvSpPr>
-            <a:spLocks noGrp="1"/>
+            <a:spLocks xmlns:a="http://schemas.openxmlformats.org/drawingml/2006/main" noGrp="1"/>
           </p:cNvSpPr>
           <p:nvPr>
             <p:ph type="title" idx="0"/>
           </p:nvPr>
         </p:nvSpPr>
         <p:spPr>
-          <a:xfrm>
+          <a:xfrm xmlns:a="http://schemas.openxmlformats.org/drawingml/2006/main">
             <a:off x="507960" y="131400"/>
             <a:ext cx="11242800" cy="1260000"/>
           </a:xfrm>
-          <a:prstGeom prst="rect">
+          <a:prstGeom xmlns:a="http://schemas.openxmlformats.org/drawingml/2006/main" prst="rect">
             <a:avLst/>
           </a:prstGeom>
-          <a:noFill/>
-          <a:ln w="0">
+          <a:noFill xmlns:a="http://schemas.openxmlformats.org/drawingml/2006/main"/>
+          <a:ln xmlns:a="http://schemas.openxmlformats.org/drawingml/2006/main" w="0">
             <a:noFill/>
           </a:ln>
         </p:spPr>
         <p:txBody>
-          <a:bodyPr lIns="91440" tIns="45720" rIns="91440" bIns="45720" anchor="ctr">
+          <a:bodyPr xmlns:a="http://schemas.openxmlformats.org/drawingml/2006/main" lIns="91440" tIns="45720" rIns="91440" bIns="45720" anchor="ctr">
             <a:noAutofit/>
           </a:bodyPr>
-          <a:lstStyle/>
-          <a:p>
+          <a:lstStyle xmlns:a="http://schemas.openxmlformats.org/drawingml/2006/main"/>
+          <a:p xmlns:a="http://schemas.openxmlformats.org/drawingml/2006/main">
             <a:pPr indent="0" algn="ctr" defTabSz="457200">
               <a:lnSpc>
                 <a:spcPct val="100000"/>
@@ -9851,42 +9851,42 @@
       <p:sp>
         <p:nvSpPr>
           <p:cNvPr id="76" name="TextBox 3">
-            <a:extLst>
+            <a:extLst xmlns:a="http://schemas.openxmlformats.org/drawingml/2006/main">
               <a:ext uri="{FF2B5EF4-FFF2-40B4-BE49-F238E27FC236}">
-                <ns2:creationId id="{D89E5E77-4B58-410D-B4A2-D67E59D88B59}"/>
+                <a16:creationId xmlns:a16="http://schemas.microsoft.com/office/drawing/2014/main" id="{D89E5E77-4B58-410D-B4A2-D67E59D88B59}"/>
               </a:ext>
             </a:extLst>
           </p:cNvPr>
           <p:cNvSpPr>
-            <a:spLocks noGrp="1"/>
+            <a:spLocks xmlns:a="http://schemas.openxmlformats.org/drawingml/2006/main" noGrp="1"/>
           </p:cNvSpPr>
           <p:nvPr/>
         </p:nvSpPr>
         <p:spPr>
-          <a:xfrm>
+          <a:xfrm xmlns:a="http://schemas.openxmlformats.org/drawingml/2006/main">
             <a:off x="365760" y="6263640"/>
             <a:ext cx="11459880" cy="384048"/>
           </a:xfrm>
-          <a:prstGeom prst="rect">
+          <a:prstGeom xmlns:a="http://schemas.openxmlformats.org/drawingml/2006/main" prst="rect">
             <a:avLst/>
           </a:prstGeom>
-          <a:noFill/>
-          <a:ln w="0">
+          <a:noFill xmlns:a="http://schemas.openxmlformats.org/drawingml/2006/main"/>
+          <a:ln xmlns:a="http://schemas.openxmlformats.org/drawingml/2006/main" w="0">
             <a:noFill/>
           </a:ln>
         </p:spPr>
         <p:style>
-          <a:lnRef idx="0"/>
-          <a:fillRef idx="0"/>
-          <a:effectRef idx="0"/>
-          <a:fontRef idx="minor"/>
+          <a:lnRef xmlns:a="http://schemas.openxmlformats.org/drawingml/2006/main" idx="0"/>
+          <a:fillRef xmlns:a="http://schemas.openxmlformats.org/drawingml/2006/main" idx="0"/>
+          <a:effectRef xmlns:a="http://schemas.openxmlformats.org/drawingml/2006/main" idx="0"/>
+          <a:fontRef xmlns:a="http://schemas.openxmlformats.org/drawingml/2006/main" idx="minor"/>
         </p:style>
         <p:txBody>
-          <a:bodyPr wrap="none" lIns="90000" tIns="45000" rIns="90000" bIns="45000" anchor="t">
+          <a:bodyPr xmlns:a="http://schemas.openxmlformats.org/drawingml/2006/main" wrap="none" lIns="90000" tIns="45000" rIns="90000" bIns="45000" anchor="t">
             <a:spAutoFit/>
           </a:bodyPr>
-          <a:lstStyle/>
-          <a:p>
+          <a:lstStyle xmlns:a="http://schemas.openxmlformats.org/drawingml/2006/main"/>
+          <a:p xmlns:a="http://schemas.openxmlformats.org/drawingml/2006/main">
             <a:pPr algn="ctr" defTabSz="457200">
               <a:lnSpc>
                 <a:spcPct val="100000"/>
@@ -9918,29 +9918,29 @@
       <p:sp>
         <p:nvSpPr>
           <p:cNvPr id="78" name="Fondo gráfico 5">
-            <a:extLst>
+            <a:extLst xmlns:a="http://schemas.openxmlformats.org/drawingml/2006/main">
               <a:ext uri="{FF2B5EF4-FFF2-40B4-BE49-F238E27FC236}">
-                <ns2:creationId id="{159EFCAB-93CF-4983-AD99-0D5D834EFD96}"/>
+                <a16:creationId xmlns:a16="http://schemas.microsoft.com/office/drawing/2014/main" id="{159EFCAB-93CF-4983-AD99-0D5D834EFD96}"/>
               </a:ext>
             </a:extLst>
           </p:cNvPr>
           <p:cNvSpPr>
-            <a:spLocks noGrp="1"/>
+            <a:spLocks xmlns:a="http://schemas.openxmlformats.org/drawingml/2006/main" noGrp="1"/>
           </p:cNvSpPr>
           <p:nvPr/>
         </p:nvSpPr>
         <p:spPr>
-          <a:xfrm>
+          <a:xfrm xmlns:a="http://schemas.openxmlformats.org/drawingml/2006/main">
             <a:off x="2552700" y="952500"/>
             <a:ext cx="7086600" cy="5010150"/>
           </a:xfrm>
-          <a:prstGeom prst="rect">
+          <a:prstGeom xmlns:a="http://schemas.openxmlformats.org/drawingml/2006/main" prst="rect">
             <a:avLst/>
           </a:prstGeom>
-          <a:solidFill>
+          <a:solidFill xmlns:a="http://schemas.openxmlformats.org/drawingml/2006/main">
             <a:srgbClr val="FFFFFF"/>
           </a:solidFill>
-          <a:ln w="0">
+          <a:ln xmlns:a="http://schemas.openxmlformats.org/drawingml/2006/main" w="0">
             <a:solidFill>
               <a:srgbClr val="FFFFFF"/>
             </a:solidFill>
@@ -9949,24 +9949,24 @@
       </p:sp>
       <p:graphicFrame>
         <p:nvGraphicFramePr>
-          <p:cNvPr id="84" name="Chart"/>
+          <p:cNvPr id="83" name="Chart"/>
           <p:cNvGraphicFramePr/>
           <p:nvPr/>
         </p:nvGraphicFramePr>
         <p:xfrm>
-          <a:off x="2095500" y="1171575"/>
-          <a:ext cx="8001000" cy="4524375"/>
+          <a:off xmlns:a="http://schemas.openxmlformats.org/drawingml/2006/main" x="2095500" y="1171575"/>
+          <a:ext xmlns:a="http://schemas.openxmlformats.org/drawingml/2006/main" cx="8001000" cy="4524375"/>
         </p:xfrm>
-        <a:graphic>
+        <a:graphic xmlns:a="http://schemas.openxmlformats.org/drawingml/2006/main">
           <a:graphicData uri="http://schemas.openxmlformats.org/drawingml/2006/chart">
-            <ns3:chart r:id="R8c303e39f5214024"/>
+            <c:chart xmlns:r="http://schemas.openxmlformats.org/officeDocument/2006/relationships" xmlns:c="http://schemas.openxmlformats.org/drawingml/2006/chart" r:id="R3f5553f40f6049bd"/>
           </a:graphicData>
         </a:graphic>
       </p:graphicFrame>
     </p:spTree>
     <p:extLst>
       <p:ext uri="{BB962C8B-B14F-4D97-AF65-F5344CB8AC3E}">
-        <ns5:creationId val="303505656"/>
+        <p14:creationId xmlns:p14="http://schemas.microsoft.com/office/powerpoint/2010/main" val="303505656"/>
       </p:ext>
     </p:extLst>
   </p:cSld>
@@ -9974,7 +9974,7 @@
 </file>
 
 <file path=ppt/slides/slide6.xml><?xml version="1.0" encoding="utf-8"?>
-<p:sld xmlns:a="http://schemas.openxmlformats.org/drawingml/2006/main" xmlns:ns2="http://schemas.microsoft.com/office/drawing/2014/main" xmlns:ns3="http://schemas.openxmlformats.org/drawingml/2006/chart" xmlns:ns5="http://schemas.microsoft.com/office/powerpoint/2010/main" xmlns:p="http://schemas.openxmlformats.org/presentationml/2006/main" xmlns:r="http://schemas.openxmlformats.org/officeDocument/2006/relationships">
+<p:sld xmlns:p="http://schemas.openxmlformats.org/presentationml/2006/main">
   <p:cSld>
     <p:spTree>
       <p:nvGrpSpPr>
@@ -9983,43 +9983,43 @@
         <p:nvPr/>
       </p:nvGrpSpPr>
       <p:grpSpPr>
-        <a:xfrm/>
+        <a:xfrm xmlns:a="http://schemas.openxmlformats.org/drawingml/2006/main"/>
       </p:grpSpPr>
       <p:sp>
         <p:nvSpPr>
           <p:cNvPr id="77" name="PlaceHolder 1">
-            <a:extLst>
+            <a:extLst xmlns:a="http://schemas.openxmlformats.org/drawingml/2006/main">
               <a:ext uri="{FF2B5EF4-FFF2-40B4-BE49-F238E27FC236}">
-                <ns2:creationId id="{68DF6AE7-B196-4300-BDC9-E0722C6EA253}"/>
+                <a16:creationId xmlns:a16="http://schemas.microsoft.com/office/drawing/2014/main" id="{68DF6AE7-B196-4300-BDC9-E0722C6EA253}"/>
               </a:ext>
             </a:extLst>
           </p:cNvPr>
           <p:cNvSpPr>
-            <a:spLocks noGrp="1"/>
+            <a:spLocks xmlns:a="http://schemas.openxmlformats.org/drawingml/2006/main" noGrp="1"/>
           </p:cNvSpPr>
           <p:nvPr>
             <p:ph type="title" idx="0"/>
           </p:nvPr>
         </p:nvSpPr>
         <p:spPr>
-          <a:xfrm>
+          <a:xfrm xmlns:a="http://schemas.openxmlformats.org/drawingml/2006/main">
             <a:off x="637200" y="180000"/>
             <a:ext cx="10522800" cy="805320"/>
           </a:xfrm>
-          <a:prstGeom prst="rect">
+          <a:prstGeom xmlns:a="http://schemas.openxmlformats.org/drawingml/2006/main" prst="rect">
             <a:avLst/>
           </a:prstGeom>
-          <a:noFill/>
-          <a:ln w="0">
+          <a:noFill xmlns:a="http://schemas.openxmlformats.org/drawingml/2006/main"/>
+          <a:ln xmlns:a="http://schemas.openxmlformats.org/drawingml/2006/main" w="0">
             <a:noFill/>
           </a:ln>
         </p:spPr>
         <p:txBody>
-          <a:bodyPr lIns="91440" tIns="45720" rIns="91440" bIns="45720" anchor="ctr">
+          <a:bodyPr xmlns:a="http://schemas.openxmlformats.org/drawingml/2006/main" lIns="91440" tIns="45720" rIns="91440" bIns="45720" anchor="ctr">
             <a:noAutofit/>
           </a:bodyPr>
-          <a:lstStyle/>
-          <a:p>
+          <a:lstStyle xmlns:a="http://schemas.openxmlformats.org/drawingml/2006/main"/>
+          <a:p xmlns:a="http://schemas.openxmlformats.org/drawingml/2006/main">
             <a:pPr indent="0" algn="ctr" defTabSz="457200">
               <a:lnSpc>
                 <a:spcPct val="100000"/>
@@ -10051,42 +10051,42 @@
       <p:sp>
         <p:nvSpPr>
           <p:cNvPr id="79" name="TextBox 3">
-            <a:extLst>
+            <a:extLst xmlns:a="http://schemas.openxmlformats.org/drawingml/2006/main">
               <a:ext uri="{FF2B5EF4-FFF2-40B4-BE49-F238E27FC236}">
-                <ns2:creationId id="{8BD09EE3-65E6-4BF7-8BB4-A3EB9FD7A8CC}"/>
+                <a16:creationId xmlns:a16="http://schemas.microsoft.com/office/drawing/2014/main" id="{8BD09EE3-65E6-4BF7-8BB4-A3EB9FD7A8CC}"/>
               </a:ext>
             </a:extLst>
           </p:cNvPr>
           <p:cNvSpPr>
-            <a:spLocks noGrp="1"/>
+            <a:spLocks xmlns:a="http://schemas.openxmlformats.org/drawingml/2006/main" noGrp="1"/>
           </p:cNvSpPr>
           <p:nvPr/>
         </p:nvSpPr>
         <p:spPr>
-          <a:xfrm>
+          <a:xfrm xmlns:a="http://schemas.openxmlformats.org/drawingml/2006/main">
             <a:off x="360000" y="6263640"/>
             <a:ext cx="11459880" cy="384048"/>
           </a:xfrm>
-          <a:prstGeom prst="rect">
+          <a:prstGeom xmlns:a="http://schemas.openxmlformats.org/drawingml/2006/main" prst="rect">
             <a:avLst/>
           </a:prstGeom>
-          <a:noFill/>
-          <a:ln w="0">
+          <a:noFill xmlns:a="http://schemas.openxmlformats.org/drawingml/2006/main"/>
+          <a:ln xmlns:a="http://schemas.openxmlformats.org/drawingml/2006/main" w="0">
             <a:noFill/>
           </a:ln>
         </p:spPr>
         <p:style>
-          <a:lnRef idx="0"/>
-          <a:fillRef idx="0"/>
-          <a:effectRef idx="0"/>
-          <a:fontRef idx="minor"/>
+          <a:lnRef xmlns:a="http://schemas.openxmlformats.org/drawingml/2006/main" idx="0"/>
+          <a:fillRef xmlns:a="http://schemas.openxmlformats.org/drawingml/2006/main" idx="0"/>
+          <a:effectRef xmlns:a="http://schemas.openxmlformats.org/drawingml/2006/main" idx="0"/>
+          <a:fontRef xmlns:a="http://schemas.openxmlformats.org/drawingml/2006/main" idx="minor"/>
         </p:style>
         <p:txBody>
-          <a:bodyPr wrap="none" lIns="90000" tIns="45000" rIns="90000" bIns="45000" anchor="t">
+          <a:bodyPr xmlns:a="http://schemas.openxmlformats.org/drawingml/2006/main" wrap="none" lIns="90000" tIns="45000" rIns="90000" bIns="45000" anchor="t">
             <a:spAutoFit/>
           </a:bodyPr>
-          <a:lstStyle/>
-          <a:p>
+          <a:lstStyle xmlns:a="http://schemas.openxmlformats.org/drawingml/2006/main"/>
+          <a:p xmlns:a="http://schemas.openxmlformats.org/drawingml/2006/main">
             <a:pPr algn="ctr" defTabSz="457200">
               <a:lnSpc>
                 <a:spcPct val="100000"/>
@@ -10118,29 +10118,29 @@
       <p:sp>
         <p:nvSpPr>
           <p:cNvPr id="81" name="Fondo gráfico 6">
-            <a:extLst>
+            <a:extLst xmlns:a="http://schemas.openxmlformats.org/drawingml/2006/main">
               <a:ext uri="{FF2B5EF4-FFF2-40B4-BE49-F238E27FC236}">
-                <ns2:creationId id="{00442256-553E-4777-B321-F210439A2046}"/>
+                <a16:creationId xmlns:a16="http://schemas.microsoft.com/office/drawing/2014/main" id="{00442256-553E-4777-B321-F210439A2046}"/>
               </a:ext>
             </a:extLst>
           </p:cNvPr>
           <p:cNvSpPr>
-            <a:spLocks noGrp="1"/>
+            <a:spLocks xmlns:a="http://schemas.openxmlformats.org/drawingml/2006/main" noGrp="1"/>
           </p:cNvSpPr>
           <p:nvPr/>
         </p:nvSpPr>
         <p:spPr>
-          <a:xfrm>
+          <a:xfrm xmlns:a="http://schemas.openxmlformats.org/drawingml/2006/main">
             <a:off x="2552700" y="952500"/>
             <a:ext cx="7086600" cy="5010150"/>
           </a:xfrm>
-          <a:prstGeom prst="rect">
+          <a:prstGeom xmlns:a="http://schemas.openxmlformats.org/drawingml/2006/main" prst="rect">
             <a:avLst/>
           </a:prstGeom>
-          <a:solidFill>
+          <a:solidFill xmlns:a="http://schemas.openxmlformats.org/drawingml/2006/main">
             <a:srgbClr val="FFFFFF"/>
           </a:solidFill>
-          <a:ln w="0">
+          <a:ln xmlns:a="http://schemas.openxmlformats.org/drawingml/2006/main" w="0">
             <a:solidFill>
               <a:srgbClr val="FFFFFF"/>
             </a:solidFill>
@@ -10149,24 +10149,24 @@
       </p:sp>
       <p:graphicFrame>
         <p:nvGraphicFramePr>
-          <p:cNvPr id="87" name="Chart"/>
+          <p:cNvPr id="86" name="Chart"/>
           <p:cNvGraphicFramePr/>
           <p:nvPr/>
         </p:nvGraphicFramePr>
         <p:xfrm>
-          <a:off x="2095500" y="1171575"/>
-          <a:ext cx="8001000" cy="4524375"/>
+          <a:off xmlns:a="http://schemas.openxmlformats.org/drawingml/2006/main" x="2095500" y="1171575"/>
+          <a:ext xmlns:a="http://schemas.openxmlformats.org/drawingml/2006/main" cx="8001000" cy="4524375"/>
         </p:xfrm>
-        <a:graphic>
+        <a:graphic xmlns:a="http://schemas.openxmlformats.org/drawingml/2006/main">
           <a:graphicData uri="http://schemas.openxmlformats.org/drawingml/2006/chart">
-            <ns3:chart r:id="R49f36148a9104bfa"/>
+            <c:chart xmlns:r="http://schemas.openxmlformats.org/officeDocument/2006/relationships" xmlns:c="http://schemas.openxmlformats.org/drawingml/2006/chart" r:id="Rce87028068364c8c"/>
           </a:graphicData>
         </a:graphic>
       </p:graphicFrame>
     </p:spTree>
     <p:extLst>
       <p:ext uri="{BB962C8B-B14F-4D97-AF65-F5344CB8AC3E}">
-        <ns5:creationId val="1672691024"/>
+        <p14:creationId xmlns:p14="http://schemas.microsoft.com/office/powerpoint/2010/main" val="1672691024"/>
       </p:ext>
     </p:extLst>
   </p:cSld>
@@ -10174,7 +10174,7 @@
 </file>
 
 <file path=ppt/slides/slide7.xml><?xml version="1.0" encoding="utf-8"?>
-<p:sld xmlns:a="http://schemas.openxmlformats.org/drawingml/2006/main" xmlns:ns2="http://schemas.microsoft.com/office/drawing/2014/main" xmlns:ns3="http://schemas.openxmlformats.org/drawingml/2006/chart" xmlns:ns5="http://schemas.microsoft.com/office/powerpoint/2010/main" xmlns:p="http://schemas.openxmlformats.org/presentationml/2006/main" xmlns:r="http://schemas.openxmlformats.org/officeDocument/2006/relationships">
+<p:sld xmlns:p="http://schemas.openxmlformats.org/presentationml/2006/main">
   <p:cSld>
     <p:spTree>
       <p:nvGrpSpPr>
@@ -10183,43 +10183,43 @@
         <p:nvPr/>
       </p:nvGrpSpPr>
       <p:grpSpPr>
-        <a:xfrm/>
+        <a:xfrm xmlns:a="http://schemas.openxmlformats.org/drawingml/2006/main"/>
       </p:grpSpPr>
       <p:sp>
         <p:nvSpPr>
           <p:cNvPr id="80" name="PlaceHolder 1">
-            <a:extLst>
+            <a:extLst xmlns:a="http://schemas.openxmlformats.org/drawingml/2006/main">
               <a:ext uri="{FF2B5EF4-FFF2-40B4-BE49-F238E27FC236}">
-                <ns2:creationId id="{34C86444-1BAA-4375-A625-51721868B148}"/>
+                <a16:creationId xmlns:a16="http://schemas.microsoft.com/office/drawing/2014/main" id="{34C86444-1BAA-4375-A625-51721868B148}"/>
               </a:ext>
             </a:extLst>
           </p:cNvPr>
           <p:cNvSpPr>
-            <a:spLocks noGrp="1"/>
+            <a:spLocks xmlns:a="http://schemas.openxmlformats.org/drawingml/2006/main" noGrp="1"/>
           </p:cNvSpPr>
           <p:nvPr>
             <p:ph type="title" idx="0"/>
           </p:nvPr>
         </p:nvSpPr>
         <p:spPr>
-          <a:xfrm>
+          <a:xfrm xmlns:a="http://schemas.openxmlformats.org/drawingml/2006/main">
             <a:off x="457200" y="180000"/>
             <a:ext cx="11242800" cy="805320"/>
           </a:xfrm>
-          <a:prstGeom prst="rect">
+          <a:prstGeom xmlns:a="http://schemas.openxmlformats.org/drawingml/2006/main" prst="rect">
             <a:avLst/>
           </a:prstGeom>
-          <a:noFill/>
-          <a:ln w="0">
+          <a:noFill xmlns:a="http://schemas.openxmlformats.org/drawingml/2006/main"/>
+          <a:ln xmlns:a="http://schemas.openxmlformats.org/drawingml/2006/main" w="0">
             <a:noFill/>
           </a:ln>
         </p:spPr>
         <p:txBody>
-          <a:bodyPr lIns="91440" tIns="45720" rIns="91440" bIns="45720" anchor="ctr">
+          <a:bodyPr xmlns:a="http://schemas.openxmlformats.org/drawingml/2006/main" lIns="91440" tIns="45720" rIns="91440" bIns="45720" anchor="ctr">
             <a:noAutofit/>
           </a:bodyPr>
-          <a:lstStyle/>
-          <a:p>
+          <a:lstStyle xmlns:a="http://schemas.openxmlformats.org/drawingml/2006/main"/>
+          <a:p xmlns:a="http://schemas.openxmlformats.org/drawingml/2006/main">
             <a:pPr indent="0" algn="ctr" defTabSz="457200">
               <a:lnSpc>
                 <a:spcPct val="100000"/>
@@ -10251,42 +10251,42 @@
       <p:sp>
         <p:nvSpPr>
           <p:cNvPr id="82" name="TextBox 3">
-            <a:extLst>
+            <a:extLst xmlns:a="http://schemas.openxmlformats.org/drawingml/2006/main">
               <a:ext uri="{FF2B5EF4-FFF2-40B4-BE49-F238E27FC236}">
-                <ns2:creationId id="{3DBC67BC-AB62-47CE-B97D-EBE84C4AEF3A}"/>
+                <a16:creationId xmlns:a16="http://schemas.microsoft.com/office/drawing/2014/main" id="{3DBC67BC-AB62-47CE-B97D-EBE84C4AEF3A}"/>
               </a:ext>
             </a:extLst>
           </p:cNvPr>
           <p:cNvSpPr>
-            <a:spLocks noGrp="1"/>
+            <a:spLocks xmlns:a="http://schemas.openxmlformats.org/drawingml/2006/main" noGrp="1"/>
           </p:cNvSpPr>
           <p:nvPr/>
         </p:nvSpPr>
         <p:spPr>
-          <a:xfrm>
+          <a:xfrm xmlns:a="http://schemas.openxmlformats.org/drawingml/2006/main">
             <a:off x="263880" y="6263640"/>
             <a:ext cx="11459880" cy="384048"/>
           </a:xfrm>
-          <a:prstGeom prst="rect">
+          <a:prstGeom xmlns:a="http://schemas.openxmlformats.org/drawingml/2006/main" prst="rect">
             <a:avLst/>
           </a:prstGeom>
-          <a:noFill/>
-          <a:ln w="0">
+          <a:noFill xmlns:a="http://schemas.openxmlformats.org/drawingml/2006/main"/>
+          <a:ln xmlns:a="http://schemas.openxmlformats.org/drawingml/2006/main" w="0">
             <a:noFill/>
           </a:ln>
         </p:spPr>
         <p:style>
-          <a:lnRef idx="0"/>
-          <a:fillRef idx="0"/>
-          <a:effectRef idx="0"/>
-          <a:fontRef idx="minor"/>
+          <a:lnRef xmlns:a="http://schemas.openxmlformats.org/drawingml/2006/main" idx="0"/>
+          <a:fillRef xmlns:a="http://schemas.openxmlformats.org/drawingml/2006/main" idx="0"/>
+          <a:effectRef xmlns:a="http://schemas.openxmlformats.org/drawingml/2006/main" idx="0"/>
+          <a:fontRef xmlns:a="http://schemas.openxmlformats.org/drawingml/2006/main" idx="minor"/>
         </p:style>
         <p:txBody>
-          <a:bodyPr wrap="none" lIns="90000" tIns="45000" rIns="90000" bIns="45000" anchor="t">
+          <a:bodyPr xmlns:a="http://schemas.openxmlformats.org/drawingml/2006/main" wrap="none" lIns="90000" tIns="45000" rIns="90000" bIns="45000" anchor="t">
             <a:spAutoFit/>
           </a:bodyPr>
-          <a:lstStyle/>
-          <a:p>
+          <a:lstStyle xmlns:a="http://schemas.openxmlformats.org/drawingml/2006/main"/>
+          <a:p xmlns:a="http://schemas.openxmlformats.org/drawingml/2006/main">
             <a:pPr algn="ctr" defTabSz="457200">
               <a:lnSpc>
                 <a:spcPct val="100000"/>
@@ -10318,29 +10318,29 @@
       <p:sp>
         <p:nvSpPr>
           <p:cNvPr id="84" name="Fondo gráfico 7">
-            <a:extLst>
+            <a:extLst xmlns:a="http://schemas.openxmlformats.org/drawingml/2006/main">
               <a:ext uri="{FF2B5EF4-FFF2-40B4-BE49-F238E27FC236}">
-                <ns2:creationId id="{070F6796-76D7-4070-820D-83D2D0095841}"/>
+                <a16:creationId xmlns:a16="http://schemas.microsoft.com/office/drawing/2014/main" id="{070F6796-76D7-4070-820D-83D2D0095841}"/>
               </a:ext>
             </a:extLst>
           </p:cNvPr>
           <p:cNvSpPr>
-            <a:spLocks noGrp="1"/>
+            <a:spLocks xmlns:a="http://schemas.openxmlformats.org/drawingml/2006/main" noGrp="1"/>
           </p:cNvSpPr>
           <p:nvPr/>
         </p:nvSpPr>
         <p:spPr>
-          <a:xfrm>
+          <a:xfrm xmlns:a="http://schemas.openxmlformats.org/drawingml/2006/main">
             <a:off x="2552700" y="952500"/>
             <a:ext cx="7086600" cy="5010150"/>
           </a:xfrm>
-          <a:prstGeom prst="rect">
+          <a:prstGeom xmlns:a="http://schemas.openxmlformats.org/drawingml/2006/main" prst="rect">
             <a:avLst/>
           </a:prstGeom>
-          <a:solidFill>
+          <a:solidFill xmlns:a="http://schemas.openxmlformats.org/drawingml/2006/main">
             <a:srgbClr val="FFFFFF"/>
           </a:solidFill>
-          <a:ln w="0">
+          <a:ln xmlns:a="http://schemas.openxmlformats.org/drawingml/2006/main" w="0">
             <a:solidFill>
               <a:srgbClr val="FFFFFF"/>
             </a:solidFill>
@@ -10349,24 +10349,24 @@
       </p:sp>
       <p:graphicFrame>
         <p:nvGraphicFramePr>
-          <p:cNvPr id="90" name="Chart"/>
+          <p:cNvPr id="89" name="Chart"/>
           <p:cNvGraphicFramePr/>
           <p:nvPr/>
         </p:nvGraphicFramePr>
         <p:xfrm>
-          <a:off x="2095500" y="1171575"/>
-          <a:ext cx="8001000" cy="4524375"/>
+          <a:off xmlns:a="http://schemas.openxmlformats.org/drawingml/2006/main" x="2095500" y="1171575"/>
+          <a:ext xmlns:a="http://schemas.openxmlformats.org/drawingml/2006/main" cx="8001000" cy="4524375"/>
         </p:xfrm>
-        <a:graphic>
+        <a:graphic xmlns:a="http://schemas.openxmlformats.org/drawingml/2006/main">
           <a:graphicData uri="http://schemas.openxmlformats.org/drawingml/2006/chart">
-            <ns3:chart r:id="R012aa23211094245"/>
+            <c:chart xmlns:r="http://schemas.openxmlformats.org/officeDocument/2006/relationships" xmlns:c="http://schemas.openxmlformats.org/drawingml/2006/chart" r:id="Rc97fa2d8556b4236"/>
           </a:graphicData>
         </a:graphic>
       </p:graphicFrame>
     </p:spTree>
     <p:extLst>
       <p:ext uri="{BB962C8B-B14F-4D97-AF65-F5344CB8AC3E}">
-        <ns5:creationId val="1461787212"/>
+        <p14:creationId xmlns:p14="http://schemas.microsoft.com/office/powerpoint/2010/main" val="1461787212"/>
       </p:ext>
     </p:extLst>
   </p:cSld>
@@ -10374,7 +10374,7 @@
 </file>
 
 <file path=ppt/slides/slide8.xml><?xml version="1.0" encoding="utf-8"?>
-<p:sld xmlns:a="http://schemas.openxmlformats.org/drawingml/2006/main" xmlns:ns2="http://schemas.microsoft.com/office/drawing/2014/main" xmlns:ns3="http://schemas.openxmlformats.org/drawingml/2006/chart" xmlns:ns5="http://schemas.microsoft.com/office/powerpoint/2010/main" xmlns:p="http://schemas.openxmlformats.org/presentationml/2006/main" xmlns:r="http://schemas.openxmlformats.org/officeDocument/2006/relationships">
+<p:sld xmlns:p="http://schemas.openxmlformats.org/presentationml/2006/main">
   <p:cSld>
     <p:spTree>
       <p:nvGrpSpPr>
@@ -10383,43 +10383,43 @@
         <p:nvPr/>
       </p:nvGrpSpPr>
       <p:grpSpPr>
-        <a:xfrm/>
+        <a:xfrm xmlns:a="http://schemas.openxmlformats.org/drawingml/2006/main"/>
       </p:grpSpPr>
       <p:sp>
         <p:nvSpPr>
           <p:cNvPr id="83" name="PlaceHolder 1">
-            <a:extLst>
+            <a:extLst xmlns:a="http://schemas.openxmlformats.org/drawingml/2006/main">
               <a:ext uri="{FF2B5EF4-FFF2-40B4-BE49-F238E27FC236}">
-                <ns2:creationId id="{485DE502-EFBA-44FD-BADB-C6C681436252}"/>
+                <a16:creationId xmlns:a16="http://schemas.microsoft.com/office/drawing/2014/main" id="{485DE502-EFBA-44FD-BADB-C6C681436252}"/>
               </a:ext>
             </a:extLst>
           </p:cNvPr>
           <p:cNvSpPr>
-            <a:spLocks noGrp="1"/>
+            <a:spLocks xmlns:a="http://schemas.openxmlformats.org/drawingml/2006/main" noGrp="1"/>
           </p:cNvSpPr>
           <p:nvPr>
             <p:ph type="title" idx="0"/>
           </p:nvPr>
         </p:nvSpPr>
         <p:spPr>
-          <a:xfrm>
+          <a:xfrm xmlns:a="http://schemas.openxmlformats.org/drawingml/2006/main">
             <a:off x="817200" y="0"/>
             <a:ext cx="11062800" cy="985320"/>
           </a:xfrm>
-          <a:prstGeom prst="rect">
+          <a:prstGeom xmlns:a="http://schemas.openxmlformats.org/drawingml/2006/main" prst="rect">
             <a:avLst/>
           </a:prstGeom>
-          <a:noFill/>
-          <a:ln w="0">
+          <a:noFill xmlns:a="http://schemas.openxmlformats.org/drawingml/2006/main"/>
+          <a:ln xmlns:a="http://schemas.openxmlformats.org/drawingml/2006/main" w="0">
             <a:noFill/>
           </a:ln>
         </p:spPr>
         <p:txBody>
-          <a:bodyPr lIns="91440" tIns="45720" rIns="91440" bIns="45720" anchor="ctr">
+          <a:bodyPr xmlns:a="http://schemas.openxmlformats.org/drawingml/2006/main" lIns="91440" tIns="45720" rIns="91440" bIns="45720" anchor="ctr">
             <a:noAutofit/>
           </a:bodyPr>
-          <a:lstStyle/>
-          <a:p>
+          <a:lstStyle xmlns:a="http://schemas.openxmlformats.org/drawingml/2006/main"/>
+          <a:p xmlns:a="http://schemas.openxmlformats.org/drawingml/2006/main">
             <a:pPr indent="0" algn="ctr" defTabSz="457200">
               <a:lnSpc>
                 <a:spcPct val="100000"/>
@@ -10451,42 +10451,42 @@
       <p:sp>
         <p:nvSpPr>
           <p:cNvPr id="85" name="TextBox 3">
-            <a:extLst>
+            <a:extLst xmlns:a="http://schemas.openxmlformats.org/drawingml/2006/main">
               <a:ext uri="{FF2B5EF4-FFF2-40B4-BE49-F238E27FC236}">
-                <ns2:creationId id="{AF3E641E-B559-4B63-B439-358EDFBBC910}"/>
+                <a16:creationId xmlns:a16="http://schemas.microsoft.com/office/drawing/2014/main" id="{AF3E641E-B559-4B63-B439-358EDFBBC910}"/>
               </a:ext>
             </a:extLst>
           </p:cNvPr>
           <p:cNvSpPr>
-            <a:spLocks noGrp="1"/>
+            <a:spLocks xmlns:a="http://schemas.openxmlformats.org/drawingml/2006/main" noGrp="1"/>
           </p:cNvSpPr>
           <p:nvPr/>
         </p:nvSpPr>
         <p:spPr>
-          <a:xfrm>
+          <a:xfrm xmlns:a="http://schemas.openxmlformats.org/drawingml/2006/main">
             <a:off x="302040" y="6263640"/>
             <a:ext cx="11459880" cy="384048"/>
           </a:xfrm>
-          <a:prstGeom prst="rect">
+          <a:prstGeom xmlns:a="http://schemas.openxmlformats.org/drawingml/2006/main" prst="rect">
             <a:avLst/>
           </a:prstGeom>
-          <a:noFill/>
-          <a:ln w="0">
+          <a:noFill xmlns:a="http://schemas.openxmlformats.org/drawingml/2006/main"/>
+          <a:ln xmlns:a="http://schemas.openxmlformats.org/drawingml/2006/main" w="0">
             <a:noFill/>
           </a:ln>
         </p:spPr>
         <p:style>
-          <a:lnRef idx="0"/>
-          <a:fillRef idx="0"/>
-          <a:effectRef idx="0"/>
-          <a:fontRef idx="minor"/>
+          <a:lnRef xmlns:a="http://schemas.openxmlformats.org/drawingml/2006/main" idx="0"/>
+          <a:fillRef xmlns:a="http://schemas.openxmlformats.org/drawingml/2006/main" idx="0"/>
+          <a:effectRef xmlns:a="http://schemas.openxmlformats.org/drawingml/2006/main" idx="0"/>
+          <a:fontRef xmlns:a="http://schemas.openxmlformats.org/drawingml/2006/main" idx="minor"/>
         </p:style>
         <p:txBody>
-          <a:bodyPr wrap="none" lIns="90000" tIns="45000" rIns="90000" bIns="45000" anchor="t">
+          <a:bodyPr xmlns:a="http://schemas.openxmlformats.org/drawingml/2006/main" wrap="none" lIns="90000" tIns="45000" rIns="90000" bIns="45000" anchor="t">
             <a:spAutoFit/>
           </a:bodyPr>
-          <a:lstStyle/>
-          <a:p>
+          <a:lstStyle xmlns:a="http://schemas.openxmlformats.org/drawingml/2006/main"/>
+          <a:p xmlns:a="http://schemas.openxmlformats.org/drawingml/2006/main">
             <a:pPr algn="ctr" defTabSz="457200">
               <a:lnSpc>
                 <a:spcPct val="100000"/>
@@ -10518,29 +10518,29 @@
       <p:sp>
         <p:nvSpPr>
           <p:cNvPr id="87" name="Fondo gráfico 8">
-            <a:extLst>
+            <a:extLst xmlns:a="http://schemas.openxmlformats.org/drawingml/2006/main">
               <a:ext uri="{FF2B5EF4-FFF2-40B4-BE49-F238E27FC236}">
-                <ns2:creationId id="{09819C8A-8FE9-4AF3-8A81-CA1D404C8F58}"/>
+                <a16:creationId xmlns:a16="http://schemas.microsoft.com/office/drawing/2014/main" id="{09819C8A-8FE9-4AF3-8A81-CA1D404C8F58}"/>
               </a:ext>
             </a:extLst>
           </p:cNvPr>
           <p:cNvSpPr>
-            <a:spLocks noGrp="1"/>
+            <a:spLocks xmlns:a="http://schemas.openxmlformats.org/drawingml/2006/main" noGrp="1"/>
           </p:cNvSpPr>
           <p:nvPr/>
         </p:nvSpPr>
         <p:spPr>
-          <a:xfrm>
+          <a:xfrm xmlns:a="http://schemas.openxmlformats.org/drawingml/2006/main">
             <a:off x="2552700" y="952500"/>
             <a:ext cx="7086600" cy="5010150"/>
           </a:xfrm>
-          <a:prstGeom prst="rect">
+          <a:prstGeom xmlns:a="http://schemas.openxmlformats.org/drawingml/2006/main" prst="rect">
             <a:avLst/>
           </a:prstGeom>
-          <a:solidFill>
+          <a:solidFill xmlns:a="http://schemas.openxmlformats.org/drawingml/2006/main">
             <a:srgbClr val="FFFFFF"/>
           </a:solidFill>
-          <a:ln w="0">
+          <a:ln xmlns:a="http://schemas.openxmlformats.org/drawingml/2006/main" w="0">
             <a:solidFill>
               <a:srgbClr val="FFFFFF"/>
             </a:solidFill>
@@ -10549,24 +10549,24 @@
       </p:sp>
       <p:graphicFrame>
         <p:nvGraphicFramePr>
-          <p:cNvPr id="93" name="Chart"/>
+          <p:cNvPr id="92" name="Chart"/>
           <p:cNvGraphicFramePr/>
           <p:nvPr/>
         </p:nvGraphicFramePr>
         <p:xfrm>
-          <a:off x="2095500" y="1171575"/>
-          <a:ext cx="8001000" cy="4524375"/>
+          <a:off xmlns:a="http://schemas.openxmlformats.org/drawingml/2006/main" x="2095500" y="1171575"/>
+          <a:ext xmlns:a="http://schemas.openxmlformats.org/drawingml/2006/main" cx="8001000" cy="4524375"/>
         </p:xfrm>
-        <a:graphic>
+        <a:graphic xmlns:a="http://schemas.openxmlformats.org/drawingml/2006/main">
           <a:graphicData uri="http://schemas.openxmlformats.org/drawingml/2006/chart">
-            <ns3:chart r:id="R260bb3c1307744be"/>
+            <c:chart xmlns:r="http://schemas.openxmlformats.org/officeDocument/2006/relationships" xmlns:c="http://schemas.openxmlformats.org/drawingml/2006/chart" r:id="R27cd729fa30d43bd"/>
           </a:graphicData>
         </a:graphic>
       </p:graphicFrame>
     </p:spTree>
     <p:extLst>
       <p:ext uri="{BB962C8B-B14F-4D97-AF65-F5344CB8AC3E}">
-        <ns5:creationId val="78240608"/>
+        <p14:creationId xmlns:p14="http://schemas.microsoft.com/office/powerpoint/2010/main" val="78240608"/>
       </p:ext>
     </p:extLst>
   </p:cSld>
@@ -10666,8 +10666,8 @@
         </p:nvSpPr>
         <p:spPr>
           <a:xfrm xmlns:a="http://schemas.openxmlformats.org/drawingml/2006/main">
-            <a:off x="457200" y="1600200"/>
-            <a:ext cx="8229240" cy="4525560"/>
+            <a:off x="475488" y="1490472"/>
+            <a:ext cx="11201400" cy="5074920"/>
           </a:xfrm>
           <a:prstGeom xmlns:a="http://schemas.openxmlformats.org/drawingml/2006/main" prst="rect">
             <a:avLst/>
@@ -10678,7 +10678,7 @@
           </a:ln>
         </p:spPr>
         <p:txBody>
-          <a:bodyPr xmlns:a="http://schemas.openxmlformats.org/drawingml/2006/main" lIns="91440" tIns="45720" rIns="91440" bIns="45720" anchor="t">
+          <a:bodyPr xmlns:a="http://schemas.openxmlformats.org/drawingml/2006/main" lIns="54864" tIns="18288" rIns="54864" bIns="18288" anchor="t">
             <a:noAutofit/>
           </a:bodyPr>
           <a:lstStyle xmlns:a="http://schemas.openxmlformats.org/drawingml/2006/main"/>
@@ -10688,8 +10688,11 @@
                 <a:spcPct val="100000"/>
               </a:lnSpc>
               <a:spcBef>
-                <a:spcPts val="641"/>
+                <a:spcPts val="0"/>
               </a:spcBef>
+              <a:spcAft>
+                <a:spcPts val="1000"/>
+              </a:spcAft>
               <a:buClr>
                 <a:srgbClr val="000000"/>
               </a:buClr>
@@ -10697,7 +10700,7 @@
               <a:buChar char="•"/>
             </a:pPr>
             <a:r>
-              <a:rPr sz="3200" b="0" u="none">
+              <a:rPr sz="2400" b="0" u="none">
                 <a:solidFill>
                   <a:schemeClr val="dk1"/>
                 </a:solidFill>
@@ -10705,7 +10708,18 @@
                 <a:ea typeface="Calibri"/>
                 <a:cs typeface="Calibri"/>
               </a:rPr>
-              <a:t>Regresión Logística: ROC/PR 0,819/0,552; Random Forest, F1 0,544.</a:t>
+              <a:t>Modelos: Regresión Logística lidera ROC-AUC/PR-AUC (0,819/0,552); </a:t>
+            </a:r>
+            <a:r>
+              <a:rPr sz="2400" b="0" u="none">
+                <a:solidFill>
+                  <a:schemeClr val="dk1"/>
+                </a:solidFill>
+                <a:latin typeface="Calibri"/>
+                <a:ea typeface="Calibri"/>
+                <a:cs typeface="Calibri"/>
+              </a:rPr>
+              <a:t>Random Forest obtiene el F1 comparativo más alto (0,544). Umbral OOF de Regresión Logística: 0,732.</a:t>
             </a:r>
             <a:endParaRPr sz="3200" b="0" u="none">
               <a:solidFill>
@@ -10722,8 +10736,11 @@
                 <a:spcPct val="100000"/>
               </a:lnSpc>
               <a:spcBef>
-                <a:spcPts val="641"/>
+                <a:spcPts val="0"/>
               </a:spcBef>
+              <a:spcAft>
+                <a:spcPts val="1000"/>
+              </a:spcAft>
               <a:buClr>
                 <a:srgbClr val="000000"/>
               </a:buClr>
@@ -10731,7 +10748,7 @@
               <a:buChar char="•"/>
             </a:pPr>
             <a:r>
-              <a:rPr sz="3200" b="0" u="none">
+              <a:rPr sz="2400" b="0" u="none">
                 <a:solidFill>
                   <a:schemeClr val="dk1"/>
                 </a:solidFill>
@@ -10739,7 +10756,7 @@
                 <a:ea typeface="Calibri"/>
                 <a:cs typeface="Calibri"/>
               </a:rPr>
-              <a:t>Ventas: 20,6 % (92/446), 104 señales. Revisar viajes, objetivos y carga.</a:t>
+              <a:t>Ventas (20,6 %; 92/446; 104 señales): revisar viajes, objetivos y carga comercial.</a:t>
             </a:r>
             <a:endParaRPr sz="3200" b="0" u="none">
               <a:solidFill>
@@ -10756,8 +10773,11 @@
                 <a:spcPct val="100000"/>
               </a:lnSpc>
               <a:spcBef>
-                <a:spcPts val="641"/>
+                <a:spcPts val="0"/>
               </a:spcBef>
+              <a:spcAft>
+                <a:spcPts val="1000"/>
+              </a:spcAft>
               <a:buClr>
                 <a:srgbClr val="000000"/>
               </a:buClr>
@@ -10765,7 +10785,7 @@
               <a:buChar char="•"/>
             </a:pPr>
             <a:r>
-              <a:rPr sz="3200" b="0" u="none">
+              <a:rPr sz="2400" b="0" u="none">
                 <a:solidFill>
                   <a:schemeClr val="dk1"/>
                 </a:solidFill>
@@ -10773,7 +10793,7 @@
                 <a:ea typeface="Calibri"/>
                 <a:cs typeface="Calibri"/>
               </a:rPr>
-              <a:t>I+D: 115 señales y 133 salidas; priorizar equipos y puestos.</a:t>
+              <a:t>I+D (13,8 %; 133/961; 115 señales): priorizar equipos y puestos con más salidas.</a:t>
             </a:r>
             <a:endParaRPr sz="3200" b="0" u="none">
               <a:solidFill>
@@ -10790,8 +10810,11 @@
                 <a:spcPct val="100000"/>
               </a:lnSpc>
               <a:spcBef>
-                <a:spcPts val="641"/>
+                <a:spcPts val="0"/>
               </a:spcBef>
+              <a:spcAft>
+                <a:spcPts val="1000"/>
+              </a:spcAft>
               <a:buClr>
                 <a:srgbClr val="000000"/>
               </a:buClr>
@@ -10799,7 +10822,7 @@
               <a:buChar char="•"/>
             </a:pPr>
             <a:r>
-              <a:rPr sz="3200" b="0" u="none">
+              <a:rPr sz="2400" b="0" u="none">
                 <a:solidFill>
                   <a:schemeClr val="dk1"/>
                 </a:solidFill>
@@ -10807,7 +10830,7 @@
                 <a:ea typeface="Calibri"/>
                 <a:cs typeface="Calibri"/>
               </a:rPr>
-              <a:t>Horas extra: 30,5 % vs. 10,4 %. Revisar turnos y carga.</a:t>
+              <a:t>Horas extra (30,5 % frente a 10,4 %): revisar turnos y distribuir mejor la carga.</a:t>
             </a:r>
             <a:endParaRPr sz="3200" b="0" u="none">
               <a:solidFill>
@@ -10824,8 +10847,11 @@
                 <a:spcPct val="100000"/>
               </a:lnSpc>
               <a:spcBef>
-                <a:spcPts val="641"/>
+                <a:spcPts val="0"/>
               </a:spcBef>
+              <a:spcAft>
+                <a:spcPts val="1000"/>
+              </a:spcAft>
               <a:buClr>
                 <a:srgbClr val="000000"/>
               </a:buClr>
@@ -10833,7 +10859,7 @@
               <a:buChar char="•"/>
             </a:pPr>
             <a:r>
-              <a:rPr sz="3200" b="0" u="none">
+              <a:rPr sz="2400" b="0" u="none">
                 <a:solidFill>
                   <a:schemeClr val="dk1"/>
                 </a:solidFill>
@@ -10841,7 +10867,7 @@
                 <a:ea typeface="Calibri"/>
                 <a:cs typeface="Calibri"/>
               </a:rPr>
-              <a:t>RR. HH.: 19 % (12/63), 9 señales. Medir antes y después.</a:t>
+              <a:t>Recursos Humanos (19 %; 12/63; 9 señales): ajustar revisión al tamaño del área. Iniciar pilotos en Ventas y equipos con más horas extra; medir antes y después.</a:t>
             </a:r>
             <a:endParaRPr sz="3200" b="0" u="none">
               <a:solidFill>

</xml_diff>